<commit_message>
docs(wbs): sync T1048 completion to github report and calendar ics
</commit_message>
<xml_diff>
--- a/exports/knowledge_flow/mighty_skill_bridge_ceo_presentation_2026-06-02_figma-modern.pptx
+++ b/exports/knowledge_flow/mighty_skill_bridge_ceo_presentation_2026-06-02_figma-modern.pptx
@@ -5114,7 +5114,7 @@
                 </a:solidFill>
                 <a:latin typeface="Plus Jakarta Sans"/>
               </a:rPr>
-              <a:t>429 Tasks</a:t>
+              <a:t>474 Tasks</a:t>
             </a:r>
           </a:p>
         </p:txBody>
@@ -5544,7 +5544,7 @@
                 </a:solidFill>
                 <a:latin typeface="Consolas"/>
               </a:rPr>
-              <a:t>•  Public URL: https://kanta13jp1.github.io/mighty-link-ai-connect/</a:t>
+              <a:t>•  Production URL: https://mightylink-app.com/</a:t>
             </a:r>
           </a:p>
           <a:p>

</xml_diff>